<commit_message>
Rebuild deck with compressed JPEG slide media
Ensure the PowerPoint embeds the lightweight hero crops so the file
stays small and opens quickly while remaining fully editable.

Co-authored-by: unmegonzales <unmegonzales@users.noreply.github.com>
</commit_message>
<xml_diff>
--- a/presentation/Visitor-File-Submissions.pptx
+++ b/presentation/Visitor-File-Submissions.pptx
@@ -3142,7 +3142,7 @@
       </p:sp>
       <p:pic>
         <p:nvPicPr>
-          <p:cNvPr id="3" name="Picture 2" descr="hero-widescreen.png"/>
+          <p:cNvPr id="3" name="Picture 2" descr="hero-widescreen.jpg"/>
           <p:cNvPicPr>
             <a:picLocks noChangeAspect="1"/>
           </p:cNvPicPr>
@@ -3632,7 +3632,7 @@
       </p:sp>
       <p:pic>
         <p:nvPicPr>
-          <p:cNvPr id="3" name="Picture 2" descr="hero-widescreen.png"/>
+          <p:cNvPr id="3" name="Picture 2" descr="hero-widescreen.jpg"/>
           <p:cNvPicPr>
             <a:picLocks noChangeAspect="1"/>
           </p:cNvPicPr>
@@ -8301,7 +8301,7 @@
       </p:sp>
       <p:pic>
         <p:nvPicPr>
-          <p:cNvPr id="3" name="Picture 2" descr="hero-panel.png"/>
+          <p:cNvPr id="3" name="Picture 2" descr="hero-panel.jpg"/>
           <p:cNvPicPr>
             <a:picLocks noChangeAspect="1"/>
           </p:cNvPicPr>

</xml_diff>